<commit_message>
Add Frame 변화 필터링 step to workflow 2 status report
filter_frames_by_change is the CV-based preprocessing that removes static
frames before the VLM probes (sem_monitor_box, cursor_click) run.  Insert it
as the first WF2 step so the flow accurately reflects how captured frames
are reduced before VLM input.

Co-Authored-By: Claude Opus 4.7 (1M context) <noreply@anthropic.com>
</commit_message>
<xml_diff>
--- a/poc/workflow_2/docs/workflow_2_status_report.pptx
+++ b/poc/workflow_2/docs/workflow_2_status_report.pptx
@@ -3743,7 +3743,7 @@
         <p:spPr>
           <a:xfrm>
             <a:off x="457200" y="3291840"/>
-            <a:ext cx="2139696" cy="2194560"/>
+            <a:ext cx="1760220" cy="2194560"/>
           </a:xfrm>
           <a:prstGeom prst="roundRect">
             <a:avLst/>
@@ -3796,7 +3796,7 @@
                 </a:solidFill>
                 <a:latin typeface="Malgun Gothic"/>
               </a:rPr>
-              <a:t>SEM Monitor Box 인식</a:t>
+              <a:t>Frame 변화 필터링 (CV)</a:t>
             </a:r>
           </a:p>
           <a:p>
@@ -3808,7 +3808,7 @@
                 </a:solidFill>
                 <a:latin typeface="Malgun Gothic"/>
               </a:rPr>
-              <a:t>VLM이 live SEM 영역 bbox를 식별 (제어 패널 가림에도 정상 동작)</a:t>
+              <a:t>cv2.absdiff·dilate·connectedComponents로 정적 프레임 제거, VLM 입력량 축소</a:t>
             </a:r>
           </a:p>
         </p:txBody>
@@ -3821,7 +3821,7 @@
         </p:nvCxnSpPr>
         <p:spPr>
           <a:xfrm>
-            <a:off x="2596896" y="4389120"/>
+            <a:off x="2217420" y="4389120"/>
             <a:ext cx="137160" cy="0"/>
           </a:xfrm>
           <a:prstGeom prst="line">
@@ -3856,8 +3856,122 @@
         </p:nvSpPr>
         <p:spPr>
           <a:xfrm>
-            <a:off x="2734056" y="3291840"/>
-            <a:ext cx="2139696" cy="2194560"/>
+            <a:off x="2354580" y="3291840"/>
+            <a:ext cx="1760220" cy="2194560"/>
+          </a:xfrm>
+          <a:prstGeom prst="roundRect">
+            <a:avLst/>
+          </a:prstGeom>
+          <a:solidFill>
+            <a:srgbClr val="E8F5E9"/>
+          </a:solidFill>
+          <a:ln w="25400">
+            <a:solidFill>
+              <a:srgbClr val="2E7D32"/>
+            </a:solidFill>
+          </a:ln>
+          <a:effectLst/>
+        </p:spPr>
+        <p:style>
+          <a:lnRef idx="1">
+            <a:schemeClr val="accent1"/>
+          </a:lnRef>
+          <a:fillRef idx="3">
+            <a:schemeClr val="accent1"/>
+          </a:fillRef>
+          <a:effectRef idx="2">
+            <a:schemeClr val="accent1"/>
+          </a:effectRef>
+          <a:fontRef idx="minor">
+            <a:schemeClr val="lt1"/>
+          </a:fontRef>
+        </p:style>
+        <p:txBody>
+          <a:bodyPr rtlCol="0" anchor="ctr" wrap="square" tIns="73152" bIns="73152"/>
+          <a:lstStyle/>
+          <a:p>
+            <a:pPr algn="ctr"/>
+            <a:r>
+              <a:rPr sz="900" b="1">
+                <a:solidFill>
+                  <a:srgbClr val="1B5E20"/>
+                </a:solidFill>
+                <a:latin typeface="Malgun Gothic"/>
+              </a:rPr>
+              <a:t>✅ 완료</a:t>
+            </a:r>
+          </a:p>
+          <a:p>
+            <a:pPr algn="ctr"/>
+            <a:r>
+              <a:rPr sz="1100" b="1">
+                <a:solidFill>
+                  <a:srgbClr val="1B5E20"/>
+                </a:solidFill>
+                <a:latin typeface="Malgun Gothic"/>
+              </a:rPr>
+              <a:t>SEM Monitor Box 인식</a:t>
+            </a:r>
+          </a:p>
+          <a:p>
+            <a:pPr algn="ctr"/>
+            <a:r>
+              <a:rPr sz="800" b="0">
+                <a:solidFill>
+                  <a:srgbClr val="1B5E20"/>
+                </a:solidFill>
+                <a:latin typeface="Malgun Gothic"/>
+              </a:rPr>
+              <a:t>VLM이 live SEM 영역 bbox를 식별 (제어 패널 가림에도 정상 동작)</a:t>
+            </a:r>
+          </a:p>
+        </p:txBody>
+      </p:sp>
+      <p:cxnSp>
+        <p:nvCxnSpPr>
+          <p:cNvPr id="16" name="Connector 15"/>
+          <p:cNvCxnSpPr/>
+          <p:nvPr/>
+        </p:nvCxnSpPr>
+        <p:spPr>
+          <a:xfrm>
+            <a:off x="4114800" y="4389120"/>
+            <a:ext cx="137160" cy="0"/>
+          </a:xfrm>
+          <a:prstGeom prst="line">
+            <a:avLst/>
+          </a:prstGeom>
+          <a:ln w="19050">
+            <a:solidFill>
+              <a:srgbClr val="90A4AE"/>
+            </a:solidFill>
+          </a:ln>
+        </p:spPr>
+        <p:style>
+          <a:lnRef idx="2">
+            <a:schemeClr val="accent1"/>
+          </a:lnRef>
+          <a:fillRef idx="0">
+            <a:schemeClr val="accent1"/>
+          </a:fillRef>
+          <a:effectRef idx="1">
+            <a:schemeClr val="accent1"/>
+          </a:effectRef>
+          <a:fontRef idx="minor">
+            <a:schemeClr val="tx1"/>
+          </a:fontRef>
+        </p:style>
+      </p:cxnSp>
+      <p:sp>
+        <p:nvSpPr>
+          <p:cNvPr id="17" name="Rounded Rectangle 16"/>
+          <p:cNvSpPr/>
+          <p:nvPr/>
+        </p:nvSpPr>
+        <p:spPr>
+          <a:xfrm>
+            <a:off x="4251960" y="3291840"/>
+            <a:ext cx="1760220" cy="2194560"/>
           </a:xfrm>
           <a:prstGeom prst="roundRect">
             <a:avLst/>
@@ -3929,13 +4043,13 @@
       </p:sp>
       <p:sp>
         <p:nvSpPr>
-          <p:cNvPr id="16" name="Rounded Rectangle 15"/>
+          <p:cNvPr id="18" name="Rounded Rectangle 17"/>
           <p:cNvSpPr/>
           <p:nvPr/>
         </p:nvSpPr>
         <p:spPr>
           <a:xfrm>
-            <a:off x="3346704" y="3163824"/>
+            <a:off x="4674870" y="3163824"/>
             <a:ext cx="914400" cy="256032"/>
           </a:xfrm>
           <a:prstGeom prst="roundRect">
@@ -3982,13 +4096,13 @@
       </p:sp>
       <p:cxnSp>
         <p:nvCxnSpPr>
-          <p:cNvPr id="17" name="Connector 16"/>
+          <p:cNvPr id="19" name="Connector 18"/>
           <p:cNvCxnSpPr/>
           <p:nvPr/>
         </p:nvCxnSpPr>
         <p:spPr>
           <a:xfrm>
-            <a:off x="4873752" y="4389120"/>
+            <a:off x="6012180" y="4389120"/>
             <a:ext cx="137160" cy="0"/>
           </a:xfrm>
           <a:prstGeom prst="line">
@@ -4017,14 +4131,14 @@
       </p:cxnSp>
       <p:sp>
         <p:nvSpPr>
-          <p:cNvPr id="18" name="Rounded Rectangle 17"/>
+          <p:cNvPr id="20" name="Rounded Rectangle 19"/>
           <p:cNvSpPr/>
           <p:nvPr/>
         </p:nvSpPr>
         <p:spPr>
           <a:xfrm>
-            <a:off x="5010912" y="3291840"/>
-            <a:ext cx="2139696" cy="2194560"/>
+            <a:off x="6149340" y="3291840"/>
+            <a:ext cx="1760220" cy="2194560"/>
           </a:xfrm>
           <a:prstGeom prst="roundRect">
             <a:avLst/>
@@ -4096,13 +4210,13 @@
       </p:sp>
       <p:sp>
         <p:nvSpPr>
-          <p:cNvPr id="19" name="Rounded Rectangle 18"/>
+          <p:cNvPr id="21" name="Rounded Rectangle 20"/>
           <p:cNvSpPr/>
           <p:nvPr/>
         </p:nvSpPr>
         <p:spPr>
           <a:xfrm>
-            <a:off x="5623560" y="3163824"/>
+            <a:off x="6572250" y="3163824"/>
             <a:ext cx="914400" cy="256032"/>
           </a:xfrm>
           <a:prstGeom prst="roundRect">
@@ -4149,13 +4263,13 @@
       </p:sp>
       <p:cxnSp>
         <p:nvCxnSpPr>
-          <p:cNvPr id="20" name="Connector 19"/>
+          <p:cNvPr id="22" name="Connector 21"/>
           <p:cNvCxnSpPr/>
           <p:nvPr/>
         </p:nvCxnSpPr>
         <p:spPr>
           <a:xfrm>
-            <a:off x="7150608" y="4389120"/>
+            <a:off x="7909560" y="4389120"/>
             <a:ext cx="137160" cy="0"/>
           </a:xfrm>
           <a:prstGeom prst="line">
@@ -4184,14 +4298,14 @@
       </p:cxnSp>
       <p:sp>
         <p:nvSpPr>
-          <p:cNvPr id="21" name="Rounded Rectangle 20"/>
+          <p:cNvPr id="23" name="Rounded Rectangle 22"/>
           <p:cNvSpPr/>
           <p:nvPr/>
         </p:nvSpPr>
         <p:spPr>
           <a:xfrm>
-            <a:off x="7287768" y="3291840"/>
-            <a:ext cx="2139696" cy="2194560"/>
+            <a:off x="8046720" y="3291840"/>
+            <a:ext cx="1760220" cy="2194560"/>
           </a:xfrm>
           <a:prstGeom prst="roundRect">
             <a:avLst/>
@@ -4263,13 +4377,13 @@
       </p:sp>
       <p:cxnSp>
         <p:nvCxnSpPr>
-          <p:cNvPr id="22" name="Connector 21"/>
+          <p:cNvPr id="24" name="Connector 23"/>
           <p:cNvCxnSpPr/>
           <p:nvPr/>
         </p:nvCxnSpPr>
         <p:spPr>
           <a:xfrm>
-            <a:off x="9427464" y="4389120"/>
+            <a:off x="9806940" y="4389120"/>
             <a:ext cx="137160" cy="0"/>
           </a:xfrm>
           <a:prstGeom prst="line">
@@ -4298,14 +4412,14 @@
       </p:cxnSp>
       <p:sp>
         <p:nvSpPr>
-          <p:cNvPr id="23" name="Rounded Rectangle 22"/>
+          <p:cNvPr id="25" name="Rounded Rectangle 24"/>
           <p:cNvSpPr/>
           <p:nvPr/>
         </p:nvSpPr>
         <p:spPr>
           <a:xfrm>
-            <a:off x="9564624" y="3291840"/>
-            <a:ext cx="2139696" cy="2194560"/>
+            <a:off x="9944100" y="3291840"/>
+            <a:ext cx="1760220" cy="2194560"/>
           </a:xfrm>
           <a:prstGeom prst="roundRect">
             <a:avLst/>
@@ -4377,7 +4491,7 @@
       </p:sp>
       <p:sp>
         <p:nvSpPr>
-          <p:cNvPr id="24" name="Rectangle 23"/>
+          <p:cNvPr id="26" name="Rectangle 25"/>
           <p:cNvSpPr/>
           <p:nvPr/>
         </p:nvSpPr>
@@ -4423,7 +4537,7 @@
       </p:sp>
       <p:sp>
         <p:nvSpPr>
-          <p:cNvPr id="25" name="TextBox 24"/>
+          <p:cNvPr id="27" name="TextBox 26"/>
           <p:cNvSpPr txBox="1"/>
           <p:nvPr/>
         </p:nvSpPr>
@@ -4458,7 +4572,7 @@
       </p:sp>
       <p:sp>
         <p:nvSpPr>
-          <p:cNvPr id="26" name="Rectangle 25"/>
+          <p:cNvPr id="28" name="Rectangle 27"/>
           <p:cNvSpPr/>
           <p:nvPr/>
         </p:nvSpPr>
@@ -4504,7 +4618,7 @@
       </p:sp>
       <p:sp>
         <p:nvSpPr>
-          <p:cNvPr id="27" name="TextBox 26"/>
+          <p:cNvPr id="29" name="TextBox 28"/>
           <p:cNvSpPr txBox="1"/>
           <p:nvPr/>
         </p:nvSpPr>
@@ -4539,7 +4653,7 @@
       </p:sp>
       <p:sp>
         <p:nvSpPr>
-          <p:cNvPr id="28" name="Rectangle 27"/>
+          <p:cNvPr id="30" name="Rectangle 29"/>
           <p:cNvSpPr/>
           <p:nvPr/>
         </p:nvSpPr>
@@ -4585,7 +4699,7 @@
       </p:sp>
       <p:sp>
         <p:nvSpPr>
-          <p:cNvPr id="29" name="TextBox 28"/>
+          <p:cNvPr id="31" name="TextBox 30"/>
           <p:cNvSpPr txBox="1"/>
           <p:nvPr/>
         </p:nvSpPr>
@@ -4730,7 +4844,7 @@
                 <a:gridCol w="1463040"/>
                 <a:gridCol w="6309360"/>
               </a:tblGrid>
-              <a:tr h="822960">
+              <a:tr h="705394">
                 <a:tc>
                   <a:txBody>
                     <a:bodyPr lIns="73152" rIns="73152"/>
@@ -4824,7 +4938,7 @@
                   </a:tcPr>
                 </a:tc>
               </a:tr>
-              <a:tr h="822960">
+              <a:tr h="705394">
                 <a:tc>
                   <a:txBody>
                     <a:bodyPr wrap="square" lIns="73152" rIns="73152" tIns="54864" bIns="54864" anchor="ctr"/>
@@ -4861,7 +4975,7 @@
                           </a:solidFill>
                           <a:latin typeface="Malgun Gothic"/>
                         </a:rPr>
-                        <a:t>SEM Monitor Box 인식</a:t>
+                        <a:t>Frame 변화 필터링 (CV)</a:t>
                       </a:r>
                     </a:p>
                   </a:txBody>
@@ -4907,7 +5021,7 @@
                           </a:solidFill>
                           <a:latin typeface="Malgun Gothic"/>
                         </a:rPr>
-                        <a:t>VLM이 live SEM 영역 bbox를 식별 (제어 패널 가림에도 정상 동작)</a:t>
+                        <a:t>cv2.absdiff·dilate·connectedComponents로 정적 프레임 제거, VLM 입력량 축소</a:t>
                       </a:r>
                     </a:p>
                   </a:txBody>
@@ -4918,7 +5032,7 @@
                   </a:tcPr>
                 </a:tc>
               </a:tr>
-              <a:tr h="822960">
+              <a:tr h="705394">
                 <a:tc>
                   <a:txBody>
                     <a:bodyPr wrap="square" lIns="73152" rIns="73152" tIns="54864" bIns="54864" anchor="ctr"/>
@@ -4933,6 +5047,100 @@
                           <a:latin typeface="Malgun Gothic"/>
                         </a:rPr>
                         <a:t>2</a:t>
+                      </a:r>
+                    </a:p>
+                  </a:txBody>
+                  <a:tcPr>
+                    <a:solidFill>
+                      <a:srgbClr val="FAFAFA"/>
+                    </a:solidFill>
+                  </a:tcPr>
+                </a:tc>
+                <a:tc>
+                  <a:txBody>
+                    <a:bodyPr wrap="square" lIns="73152" rIns="73152" tIns="54864" bIns="54864" anchor="ctr"/>
+                    <a:lstStyle/>
+                    <a:p>
+                      <a:pPr algn="l"/>
+                      <a:r>
+                        <a:rPr sz="1200" b="1">
+                          <a:solidFill>
+                            <a:srgbClr val="212121"/>
+                          </a:solidFill>
+                          <a:latin typeface="Malgun Gothic"/>
+                        </a:rPr>
+                        <a:t>SEM Monitor Box 인식</a:t>
+                      </a:r>
+                    </a:p>
+                  </a:txBody>
+                  <a:tcPr>
+                    <a:solidFill>
+                      <a:srgbClr val="FAFAFA"/>
+                    </a:solidFill>
+                  </a:tcPr>
+                </a:tc>
+                <a:tc>
+                  <a:txBody>
+                    <a:bodyPr wrap="square" lIns="73152" rIns="73152" tIns="54864" bIns="54864" anchor="ctr"/>
+                    <a:lstStyle/>
+                    <a:p>
+                      <a:pPr algn="ctr"/>
+                      <a:r>
+                        <a:rPr sz="1100" b="1">
+                          <a:solidFill>
+                            <a:srgbClr val="1B5E20"/>
+                          </a:solidFill>
+                          <a:latin typeface="Malgun Gothic"/>
+                        </a:rPr>
+                        <a:t>✅ 완료</a:t>
+                      </a:r>
+                    </a:p>
+                  </a:txBody>
+                  <a:tcPr>
+                    <a:solidFill>
+                      <a:srgbClr val="FAFAFA"/>
+                    </a:solidFill>
+                  </a:tcPr>
+                </a:tc>
+                <a:tc>
+                  <a:txBody>
+                    <a:bodyPr wrap="square" lIns="73152" rIns="73152" tIns="54864" bIns="54864" anchor="ctr"/>
+                    <a:lstStyle/>
+                    <a:p>
+                      <a:pPr algn="l"/>
+                      <a:r>
+                        <a:rPr sz="1100" b="0">
+                          <a:solidFill>
+                            <a:srgbClr val="424242"/>
+                          </a:solidFill>
+                          <a:latin typeface="Malgun Gothic"/>
+                        </a:rPr>
+                        <a:t>VLM이 live SEM 영역 bbox를 식별 (제어 패널 가림에도 정상 동작)</a:t>
+                      </a:r>
+                    </a:p>
+                  </a:txBody>
+                  <a:tcPr>
+                    <a:solidFill>
+                      <a:srgbClr val="FAFAFA"/>
+                    </a:solidFill>
+                  </a:tcPr>
+                </a:tc>
+              </a:tr>
+              <a:tr h="705394">
+                <a:tc>
+                  <a:txBody>
+                    <a:bodyPr wrap="square" lIns="73152" rIns="73152" tIns="54864" bIns="54864" anchor="ctr"/>
+                    <a:lstStyle/>
+                    <a:p>
+                      <a:pPr algn="ctr"/>
+                      <a:r>
+                        <a:rPr sz="1100" b="0">
+                          <a:solidFill>
+                            <a:srgbClr val="616161"/>
+                          </a:solidFill>
+                          <a:latin typeface="Malgun Gothic"/>
+                        </a:rPr>
+                        <a:t>3</a:t>
                       </a:r>
                     </a:p>
                   </a:txBody>
@@ -5012,7 +5220,7 @@
                   </a:tcPr>
                 </a:tc>
               </a:tr>
-              <a:tr h="822960">
+              <a:tr h="705394">
                 <a:tc>
                   <a:txBody>
                     <a:bodyPr wrap="square" lIns="73152" rIns="73152" tIns="54864" bIns="54864" anchor="ctr"/>
@@ -5026,7 +5234,7 @@
                           </a:solidFill>
                           <a:latin typeface="Malgun Gothic"/>
                         </a:rPr>
-                        <a:t>3</a:t>
+                        <a:t>4</a:t>
                       </a:r>
                     </a:p>
                   </a:txBody>
@@ -5106,101 +5314,7 @@
                   </a:tcPr>
                 </a:tc>
               </a:tr>
-              <a:tr h="822960">
-                <a:tc>
-                  <a:txBody>
-                    <a:bodyPr wrap="square" lIns="73152" rIns="73152" tIns="54864" bIns="54864" anchor="ctr"/>
-                    <a:lstStyle/>
-                    <a:p>
-                      <a:pPr algn="ctr"/>
-                      <a:r>
-                        <a:rPr sz="1100" b="0">
-                          <a:solidFill>
-                            <a:srgbClr val="616161"/>
-                          </a:solidFill>
-                          <a:latin typeface="Malgun Gothic"/>
-                        </a:rPr>
-                        <a:t>4</a:t>
-                      </a:r>
-                    </a:p>
-                  </a:txBody>
-                  <a:tcPr>
-                    <a:solidFill>
-                      <a:srgbClr val="FAFAFA"/>
-                    </a:solidFill>
-                  </a:tcPr>
-                </a:tc>
-                <a:tc>
-                  <a:txBody>
-                    <a:bodyPr wrap="square" lIns="73152" rIns="73152" tIns="54864" bIns="54864" anchor="ctr"/>
-                    <a:lstStyle/>
-                    <a:p>
-                      <a:pPr algn="l"/>
-                      <a:r>
-                        <a:rPr sz="1200" b="1">
-                          <a:solidFill>
-                            <a:srgbClr val="212121"/>
-                          </a:solidFill>
-                          <a:latin typeface="Malgun Gothic"/>
-                        </a:rPr>
-                        <a:t>Align Key 매칭 (Chamfer + ORB)</a:t>
-                      </a:r>
-                    </a:p>
-                  </a:txBody>
-                  <a:tcPr>
-                    <a:solidFill>
-                      <a:srgbClr val="FAFAFA"/>
-                    </a:solidFill>
-                  </a:tcPr>
-                </a:tc>
-                <a:tc>
-                  <a:txBody>
-                    <a:bodyPr wrap="square" lIns="73152" rIns="73152" tIns="54864" bIns="54864" anchor="ctr"/>
-                    <a:lstStyle/>
-                    <a:p>
-                      <a:pPr algn="ctr"/>
-                      <a:r>
-                        <a:rPr sz="1100" b="1">
-                          <a:solidFill>
-                            <a:srgbClr val="1B5E20"/>
-                          </a:solidFill>
-                          <a:latin typeface="Malgun Gothic"/>
-                        </a:rPr>
-                        <a:t>✅ 완료</a:t>
-                      </a:r>
-                    </a:p>
-                  </a:txBody>
-                  <a:tcPr>
-                    <a:solidFill>
-                      <a:srgbClr val="FAFAFA"/>
-                    </a:solidFill>
-                  </a:tcPr>
-                </a:tc>
-                <a:tc>
-                  <a:txBody>
-                    <a:bodyPr wrap="square" lIns="73152" rIns="73152" tIns="54864" bIns="54864" anchor="ctr"/>
-                    <a:lstStyle/>
-                    <a:p>
-                      <a:pPr algn="l"/>
-                      <a:r>
-                        <a:rPr sz="1100" b="0">
-                          <a:solidFill>
-                            <a:srgbClr val="424242"/>
-                          </a:solidFill>
-                          <a:latin typeface="Malgun Gothic"/>
-                        </a:rPr>
-                        <a:t>합성 데이터 검증 통과, 실데이터 calibration 대기</a:t>
-                      </a:r>
-                    </a:p>
-                  </a:txBody>
-                  <a:tcPr>
-                    <a:solidFill>
-                      <a:srgbClr val="FAFAFA"/>
-                    </a:solidFill>
-                  </a:tcPr>
-                </a:tc>
-              </a:tr>
-              <a:tr h="822960">
+              <a:tr h="705394">
                 <a:tc>
                   <a:txBody>
                     <a:bodyPr wrap="square" lIns="73152" rIns="73152" tIns="54864" bIns="54864" anchor="ctr"/>
@@ -5237,13 +5351,107 @@
                           </a:solidFill>
                           <a:latin typeface="Malgun Gothic"/>
                         </a:rPr>
+                        <a:t>Align Key 매칭 (Chamfer + ORB)</a:t>
+                      </a:r>
+                    </a:p>
+                  </a:txBody>
+                  <a:tcPr>
+                    <a:solidFill>
+                      <a:srgbClr val="FFFFFF"/>
+                    </a:solidFill>
+                  </a:tcPr>
+                </a:tc>
+                <a:tc>
+                  <a:txBody>
+                    <a:bodyPr wrap="square" lIns="73152" rIns="73152" tIns="54864" bIns="54864" anchor="ctr"/>
+                    <a:lstStyle/>
+                    <a:p>
+                      <a:pPr algn="ctr"/>
+                      <a:r>
+                        <a:rPr sz="1100" b="1">
+                          <a:solidFill>
+                            <a:srgbClr val="1B5E20"/>
+                          </a:solidFill>
+                          <a:latin typeface="Malgun Gothic"/>
+                        </a:rPr>
+                        <a:t>✅ 완료</a:t>
+                      </a:r>
+                    </a:p>
+                  </a:txBody>
+                  <a:tcPr>
+                    <a:solidFill>
+                      <a:srgbClr val="FFFFFF"/>
+                    </a:solidFill>
+                  </a:tcPr>
+                </a:tc>
+                <a:tc>
+                  <a:txBody>
+                    <a:bodyPr wrap="square" lIns="73152" rIns="73152" tIns="54864" bIns="54864" anchor="ctr"/>
+                    <a:lstStyle/>
+                    <a:p>
+                      <a:pPr algn="l"/>
+                      <a:r>
+                        <a:rPr sz="1100" b="0">
+                          <a:solidFill>
+                            <a:srgbClr val="424242"/>
+                          </a:solidFill>
+                          <a:latin typeface="Malgun Gothic"/>
+                        </a:rPr>
+                        <a:t>합성 데이터 검증 통과, 실데이터 calibration 대기</a:t>
+                      </a:r>
+                    </a:p>
+                  </a:txBody>
+                  <a:tcPr>
+                    <a:solidFill>
+                      <a:srgbClr val="FFFFFF"/>
+                    </a:solidFill>
+                  </a:tcPr>
+                </a:tc>
+              </a:tr>
+              <a:tr h="705396">
+                <a:tc>
+                  <a:txBody>
+                    <a:bodyPr wrap="square" lIns="73152" rIns="73152" tIns="54864" bIns="54864" anchor="ctr"/>
+                    <a:lstStyle/>
+                    <a:p>
+                      <a:pPr algn="ctr"/>
+                      <a:r>
+                        <a:rPr sz="1100" b="0">
+                          <a:solidFill>
+                            <a:srgbClr val="616161"/>
+                          </a:solidFill>
+                          <a:latin typeface="Malgun Gothic"/>
+                        </a:rPr>
+                        <a:t>6</a:t>
+                      </a:r>
+                    </a:p>
+                  </a:txBody>
+                  <a:tcPr>
+                    <a:solidFill>
+                      <a:srgbClr val="FAFAFA"/>
+                    </a:solidFill>
+                  </a:tcPr>
+                </a:tc>
+                <a:tc>
+                  <a:txBody>
+                    <a:bodyPr wrap="square" lIns="73152" rIns="73152" tIns="54864" bIns="54864" anchor="ctr"/>
+                    <a:lstStyle/>
+                    <a:p>
+                      <a:pPr algn="l"/>
+                      <a:r>
+                        <a:rPr sz="1200" b="1">
+                          <a:solidFill>
+                            <a:srgbClr val="212121"/>
+                          </a:solidFill>
+                          <a:latin typeface="Malgun Gothic"/>
+                        </a:rPr>
                         <a:t>FOV Search Loop</a:t>
                       </a:r>
                     </a:p>
                   </a:txBody>
                   <a:tcPr>
                     <a:solidFill>
-                      <a:srgbClr val="FFFFFF"/>
+                      <a:srgbClr val="FAFAFA"/>
                     </a:solidFill>
                   </a:tcPr>
                 </a:tc>
@@ -5266,7 +5474,7 @@
                   </a:txBody>
                   <a:tcPr>
                     <a:solidFill>
-                      <a:srgbClr val="FFFFFF"/>
+                      <a:srgbClr val="FAFAFA"/>
                     </a:solidFill>
                   </a:tcPr>
                 </a:tc>
@@ -5289,7 +5497,7 @@
                   </a:txBody>
                   <a:tcPr>
                     <a:solidFill>
-                      <a:srgbClr val="FFFFFF"/>
+                      <a:srgbClr val="FAFAFA"/>
                     </a:solidFill>
                   </a:tcPr>
                 </a:tc>

</xml_diff>

<commit_message>
auto: update poc/workflow_2/docs/generate_status_report.py (+2 more)
 poc/workflow_2/docs/generate_status_report.py     |  21 +++++++++++----------
 poc/workflow_2/docs/workflow_2_status_report.html |  13 +++++++------
 poc/workflow_2/docs/workflow_2_status_report.pptx | Bin 35176 -> 35245 bytes
 3 files changed, 18 insertions(+), 16 deletions(-)

Timestamp: 2026-05-14 09:01:28

Co-Authored-By: Claude Opus 4.6 <noreply@anthropic.com>
</commit_message>
<xml_diff>
--- a/poc/workflow_2/docs/workflow_2_status_report.pptx
+++ b/poc/workflow_2/docs/workflow_2_status_report.pptx
@@ -3226,7 +3226,7 @@
                 </a:solidFill>
                 <a:latin typeface="Malgun Gothic"/>
               </a:rPr>
-              <a:t>Workflow 1 (RCS 로그인 ~ Align Fail Alarm)은 별도 보고로 완료된 베이스라인</a:t>
+              <a:t>Workflow 1 (RCS 로그인 ~ Align Fail Alarm)은 완성 단계에 있으며, 본 보고는 Workflow 2의 진행 현황입니다</a:t>
             </a:r>
           </a:p>
         </p:txBody>
@@ -3314,7 +3314,7 @@
                 </a:solidFill>
                 <a:latin typeface="Malgun Gothic"/>
               </a:rPr>
-              <a:t>Workflow 1 (완료) → Workflow 2 (현재 작업)</a:t>
+              <a:t>Workflow 1 (완성 단계) → Workflow 2 (현재 작업)</a:t>
             </a:r>
           </a:p>
         </p:txBody>
@@ -3349,7 +3349,7 @@
                 </a:solidFill>
                 <a:latin typeface="Malgun Gothic"/>
               </a:rPr>
-              <a:t>Workflow 1 · 완료 (별도 보고됨)</a:t>
+              <a:t>Workflow 1 · 완성 단계 (별도 보고)</a:t>
             </a:r>
           </a:p>
         </p:txBody>
@@ -4311,11 +4311,11 @@
             <a:avLst/>
           </a:prstGeom>
           <a:solidFill>
-            <a:srgbClr val="E8F5E9"/>
+            <a:srgbClr val="F5F5F5"/>
           </a:solidFill>
           <a:ln w="25400">
             <a:solidFill>
-              <a:srgbClr val="2E7D32"/>
+              <a:srgbClr val="757575"/>
             </a:solidFill>
           </a:ln>
           <a:effectLst/>
@@ -4342,11 +4342,11 @@
             <a:r>
               <a:rPr sz="900" b="1">
                 <a:solidFill>
-                  <a:srgbClr val="1B5E20"/>
+                  <a:srgbClr val="424242"/>
                 </a:solidFill>
                 <a:latin typeface="Malgun Gothic"/>
               </a:rPr>
-              <a:t>✅ 완료</a:t>
+              <a:t>⏳ 대기</a:t>
             </a:r>
           </a:p>
           <a:p>
@@ -4354,7 +4354,7 @@
             <a:r>
               <a:rPr sz="1100" b="1">
                 <a:solidFill>
-                  <a:srgbClr val="1B5E20"/>
+                  <a:srgbClr val="424242"/>
                 </a:solidFill>
                 <a:latin typeface="Malgun Gothic"/>
               </a:rPr>
@@ -4366,11 +4366,11 @@
             <a:r>
               <a:rPr sz="800" b="0">
                 <a:solidFill>
-                  <a:srgbClr val="1B5E20"/>
+                  <a:srgbClr val="424242"/>
                 </a:solidFill>
                 <a:latin typeface="Malgun Gothic"/>
               </a:rPr>
-              <a:t>합성 데이터 검증 통과, 실데이터 calibration 대기</a:t>
+              <a:t>Recipe Align Key 추출 선행 필요, 합성 데이터 사전 검증만 완료된 상태</a:t>
             </a:r>
           </a:p>
         </p:txBody>
@@ -4815,7 +4815,7 @@
                 </a:solidFill>
                 <a:latin typeface="Malgun Gothic"/>
               </a:rPr>
-              <a:t>Workflow 2 5개 단계 상세</a:t>
+              <a:t>Workflow 2 6개 단계 상세</a:t>
             </a:r>
           </a:p>
         </p:txBody>
@@ -5370,11 +5370,11 @@
                       <a:r>
                         <a:rPr sz="1100" b="1">
                           <a:solidFill>
-                            <a:srgbClr val="1B5E20"/>
+                            <a:srgbClr val="424242"/>
                           </a:solidFill>
                           <a:latin typeface="Malgun Gothic"/>
                         </a:rPr>
-                        <a:t>✅ 완료</a:t>
+                        <a:t>⏳ 대기</a:t>
                       </a:r>
                     </a:p>
                   </a:txBody>
@@ -5397,7 +5397,7 @@
                           </a:solidFill>
                           <a:latin typeface="Malgun Gothic"/>
                         </a:rPr>
-                        <a:t>합성 데이터 검증 통과, 실데이터 calibration 대기</a:t>
+                        <a:t>Recipe Align Key 추출 선행 필요, 합성 데이터 사전 검증만 완료된 상태</a:t>
                       </a:r>
                     </a:p>
                   </a:txBody>
@@ -5628,7 +5628,7 @@
                 </a:solidFill>
                 <a:latin typeface="Malgun Gothic"/>
               </a:rPr>
-              <a:t>1. 실 SEM 환경 calibration 데이터 수집 (positive/negative 50+ pairs) → 매칭 임계값 검증</a:t>
+              <a:t>1. Cursor Click 감지의 환경/위치 변형 대응 마무리 후 실 RCS 회귀 테스트</a:t>
             </a:r>
           </a:p>
           <a:p>
@@ -5644,7 +5644,7 @@
                 </a:solidFill>
                 <a:latin typeface="Malgun Gothic"/>
               </a:rPr>
-              <a:t>2. Cursor Click 감지의 환경/위치 변형 대응 마무리 후 실 RCS 회귀 테스트</a:t>
+              <a:t>2. Recipe Align Key 이미지 추출 파이프라인 코어 구현 및 VLM 입력 검증</a:t>
             </a:r>
           </a:p>
           <a:p>
@@ -5660,7 +5660,7 @@
                 </a:solidFill>
                 <a:latin typeface="Malgun Gothic"/>
               </a:rPr>
-              <a:t>3. Recipe Align Key 이미지 추출 파이프라인 코어 구현 및 VLM 입력 검증</a:t>
+              <a:t>3. 추출 완료 이후 Align Key 매칭(Chamfer+ORB) 실데이터 calibration 진행 (positive/negative 50+ pairs로 임계값 검증)</a:t>
             </a:r>
           </a:p>
           <a:p>

</xml_diff>